<commit_message>
Pitch deck on the SDP hackathon template: 10 main slides and an appendix
Wording a judge could question: the 84% is marked as projected, with Neighbour Match rehoming half of what is still removed called a pilot target (the demo data rehomes 3% so far); the carbon row says it counts fittings owners would really rip out, not a 30% rule the What-if doesn't use; and AI only sorts notes into fittings, while the app counts them into the rip-out index.
</commit_message>
<xml_diff>
--- a/docs/Right-Fit-Homes-Pitch.pptx
+++ b/docs/Right-Fit-Homes-Pitch.pptx
@@ -122,13 +122,13 @@
   <p:extLst>
     <p:ext uri="{521415D9-36F7-43E2-AB2F-B90AF26B5E84}">
       <p14:sectionLst xmlns:p14="http://schemas.microsoft.com/office/powerpoint/2010/main">
-        <p14:section name="Opening" id="{8ee521ca-c901-e854-2f28-353b46c8b248}">
+        <p14:section name="Opening" id="{a27b64a4-bb29-2a0b-16d7-0aa5c262fa1d}">
           <p14:sldIdLst>
             <p14:sldId id="256"/>
             <p14:sldId id="257"/>
           </p14:sldIdLst>
         </p14:section>
-        <p14:section name="The Story" id="{c194b8f0-1ef0-c526-488d-daa0afeb7547}">
+        <p14:section name="The Story" id="{8240e8ae-7d3c-c1eb-ee89-88637ec0cf40}">
           <p14:sldIdLst>
             <p14:sldId id="258"/>
             <p14:sldId id="259"/>
@@ -136,7 +136,7 @@
             <p14:sldId id="261"/>
           </p14:sldIdLst>
         </p14:section>
-        <p14:section name="The Proof" id="{3cb94ee4-3c0b-25a9-0877-8447c76f0748}">
+        <p14:section name="The Proof" id="{ce133c75-2de2-dc97-86aa-af2f8163edfd}">
           <p14:sldIdLst>
             <p14:sldId id="262"/>
             <p14:sldId id="263"/>
@@ -146,12 +146,12 @@
             <p14:sldId id="267"/>
           </p14:sldIdLst>
         </p14:section>
-        <p14:section name="Close" id="{78e234a6-967e-287a-18bb-06635b97d3ce}">
+        <p14:section name="Close" id="{e11f0ccf-35f0-05fc-b61a-fe72ef9a51a0}">
           <p14:sldIdLst>
             <p14:sldId id="268"/>
           </p14:sldIdLst>
         </p14:section>
-        <p14:section name="Appendix" id="{d8b07612-a5a3-1191-9644-a13cce556042}">
+        <p14:section name="Appendix" id="{3c89a51c-5846-c647-af8b-74abab6adf15}">
           <p14:sldIdLst>
             <p14:sldId id="269"/>
             <p14:sldId id="270"/>
@@ -2490,7 +2490,7 @@
           <a:p>
             <a:r>
               <a:rPr lang="en-US" dirty="0"/>
-              <a:t>For a pilot of 100 terraces: of 71.6 tonnes that owners would rip out, 56 tonnes are never installed and 4 more are rehomed. That is 84%. 46.6 tonnes of CO2e never released. SDP gains about RM148,000 after running costs and pays back after 36 homes, and buyers keep RM411,000. Every input is shown, so you can question one number without rejecting the idea.</a:t>
+              <a:t>We project that for a pilot of 100 terraces, of 71.6 tonnes that owners would rip out, 56 tonnes are never installed and 4 more are rehomed. That is 84%, if Neighbour Match rehomes half of what is still removed, our target for a pilot. 46.6 tonnes of CO2e never released. SDP gains about RM148,000 after running costs and pays back after 36 homes, and buyers keep RM411,000. Every input is shown, so you can question one number without rejecting the idea.</a:t>
             </a:r>
             <a:endParaRPr lang="en-US" dirty="0"/>
           </a:p>
@@ -5282,7 +5282,7 @@
                   <a:schemeClr val="tx1"/>
                 </a:solidFill>
               </a:rPr>
-              <a:t>of rip-out waste avoided in a 100-home pilot</a:t>
+              <a:t>of rip-out waste avoided, projected for a 100-home pilot</a:t>
             </a:r>
             <a:endParaRPr lang="en-US" sz="1300" dirty="0"/>
           </a:p>
@@ -7565,7 +7565,7 @@
                           <a:ea typeface="Century Gothic" pitchFamily="34" charset="-122"/>
                           <a:cs typeface="Century Gothic" pitchFamily="34" charset="-120"/>
                         </a:rPr>
-                        <a:t>56.2 t never installed + 4.0 t rehomed (assumption: Neighbour Match rehomes 50% of reusable fittings still removed)</a:t>
+                        <a:t>56.2 t never installed + 4.0 t rehomed (target: Neighbour Match rehomes 50% of reusable fittings still removed; the demo data rehomes 3% so far)</a:t>
                       </a:r>
                       <a:endParaRPr lang="en-US" sz="1200" dirty="0">
                         <a:latin typeface="Century Gothic" charset="0"/>
@@ -12435,7 +12435,7 @@
                   <a:schemeClr val="tx2"/>
                 </a:solidFill>
               </a:rPr>
-              <a:t>AI turns owners' messy notes into a rip-out index for each house design.</a:t>
+              <a:t>AI sorts owners' messy notes into fittings; the app counts them into a rip-out index.</a:t>
             </a:r>
             <a:endParaRPr lang="en-US" sz="1300" dirty="0"/>
           </a:p>
@@ -14536,7 +14536,7 @@
                           <a:ea typeface="Century Gothic" pitchFamily="34" charset="-122"/>
                           <a:cs typeface="Century Gothic" pitchFamily="34" charset="-120"/>
                         </a:rPr>
-                        <a:t>Counted only where 30%+ of owners remove it, net of delivery trips, working shown</a:t>
+                        <a:t>Counted only for fittings owners would really rip out, net of delivery trips, working shown</a:t>
                       </a:r>
                       <a:endParaRPr lang="en-US" sz="1400" dirty="0">
                         <a:latin typeface="Century Gothic" charset="0"/>
@@ -16042,7 +16042,7 @@
                   <a:schemeClr val="tx2"/>
                 </a:solidFill>
               </a:rPr>
-              <a:t>In a 100-home pilot, 84% of the rip-out waste never happens</a:t>
+              <a:t>Projected for a 100-home pilot: 84% of the rip-out waste never happens</a:t>
             </a:r>
             <a:endParaRPr lang="en-US" sz="1800" dirty="0"/>
           </a:p>
@@ -16490,7 +16490,7 @@
                   <a:schemeClr val="tx2"/>
                 </a:solidFill>
               </a:rPr>
-              <a:t>100 double-storey terraces at the What-if page's defaults: buyers choose for 80% of would-be rip-outs, 40% of them upgrade, and Neighbour Match rehomes half of what is still removed. Simulated rip-out rates; fitting figures from public sources. Working in appendix B.</a:t>
+              <a:t>100 terraces at the What-if page's defaults: buyers choose for 80% of would-be rip-outs, 40% of them upgrade, and Neighbour Match rehomes half of the rest (a pilot target; the demo data rehomes 3% so far). Simulated rip-out rates, public fitting figures; working in appendix B.</a:t>
             </a:r>
             <a:endParaRPr lang="en-US" sz="1100" dirty="0"/>
           </a:p>

</xml_diff>